<commit_message>
Fix config for easy Colab run
</commit_message>
<xml_diff>
--- a/result_images/compare.pptx
+++ b/result_images/compare.pptx
@@ -244,7 +244,7 @@
           <a:p>
             <a:fld id="{CAE74E6A-A957-4BF9-843A-15390439D182}" type="datetimeFigureOut">
               <a:rPr lang="ko-KR" altLang="en-US" smtClean="0"/>
-              <a:t>2026-06-25</a:t>
+              <a:t>2026-06-30</a:t>
             </a:fld>
             <a:endParaRPr lang="ko-KR" altLang="en-US"/>
           </a:p>
@@ -414,7 +414,7 @@
           <a:p>
             <a:fld id="{CAE74E6A-A957-4BF9-843A-15390439D182}" type="datetimeFigureOut">
               <a:rPr lang="ko-KR" altLang="en-US" smtClean="0"/>
-              <a:t>2026-06-25</a:t>
+              <a:t>2026-06-30</a:t>
             </a:fld>
             <a:endParaRPr lang="ko-KR" altLang="en-US"/>
           </a:p>
@@ -594,7 +594,7 @@
           <a:p>
             <a:fld id="{CAE74E6A-A957-4BF9-843A-15390439D182}" type="datetimeFigureOut">
               <a:rPr lang="ko-KR" altLang="en-US" smtClean="0"/>
-              <a:t>2026-06-25</a:t>
+              <a:t>2026-06-30</a:t>
             </a:fld>
             <a:endParaRPr lang="ko-KR" altLang="en-US"/>
           </a:p>
@@ -764,7 +764,7 @@
           <a:p>
             <a:fld id="{CAE74E6A-A957-4BF9-843A-15390439D182}" type="datetimeFigureOut">
               <a:rPr lang="ko-KR" altLang="en-US" smtClean="0"/>
-              <a:t>2026-06-25</a:t>
+              <a:t>2026-06-30</a:t>
             </a:fld>
             <a:endParaRPr lang="ko-KR" altLang="en-US"/>
           </a:p>
@@ -1010,7 +1010,7 @@
           <a:p>
             <a:fld id="{CAE74E6A-A957-4BF9-843A-15390439D182}" type="datetimeFigureOut">
               <a:rPr lang="ko-KR" altLang="en-US" smtClean="0"/>
-              <a:t>2026-06-25</a:t>
+              <a:t>2026-06-30</a:t>
             </a:fld>
             <a:endParaRPr lang="ko-KR" altLang="en-US"/>
           </a:p>
@@ -1242,7 +1242,7 @@
           <a:p>
             <a:fld id="{CAE74E6A-A957-4BF9-843A-15390439D182}" type="datetimeFigureOut">
               <a:rPr lang="ko-KR" altLang="en-US" smtClean="0"/>
-              <a:t>2026-06-25</a:t>
+              <a:t>2026-06-30</a:t>
             </a:fld>
             <a:endParaRPr lang="ko-KR" altLang="en-US"/>
           </a:p>
@@ -1609,7 +1609,7 @@
           <a:p>
             <a:fld id="{CAE74E6A-A957-4BF9-843A-15390439D182}" type="datetimeFigureOut">
               <a:rPr lang="ko-KR" altLang="en-US" smtClean="0"/>
-              <a:t>2026-06-25</a:t>
+              <a:t>2026-06-30</a:t>
             </a:fld>
             <a:endParaRPr lang="ko-KR" altLang="en-US"/>
           </a:p>
@@ -1727,7 +1727,7 @@
           <a:p>
             <a:fld id="{CAE74E6A-A957-4BF9-843A-15390439D182}" type="datetimeFigureOut">
               <a:rPr lang="ko-KR" altLang="en-US" smtClean="0"/>
-              <a:t>2026-06-25</a:t>
+              <a:t>2026-06-30</a:t>
             </a:fld>
             <a:endParaRPr lang="ko-KR" altLang="en-US"/>
           </a:p>
@@ -1822,7 +1822,7 @@
           <a:p>
             <a:fld id="{CAE74E6A-A957-4BF9-843A-15390439D182}" type="datetimeFigureOut">
               <a:rPr lang="ko-KR" altLang="en-US" smtClean="0"/>
-              <a:t>2026-06-25</a:t>
+              <a:t>2026-06-30</a:t>
             </a:fld>
             <a:endParaRPr lang="ko-KR" altLang="en-US"/>
           </a:p>
@@ -2099,7 +2099,7 @@
           <a:p>
             <a:fld id="{CAE74E6A-A957-4BF9-843A-15390439D182}" type="datetimeFigureOut">
               <a:rPr lang="ko-KR" altLang="en-US" smtClean="0"/>
-              <a:t>2026-06-25</a:t>
+              <a:t>2026-06-30</a:t>
             </a:fld>
             <a:endParaRPr lang="ko-KR" altLang="en-US"/>
           </a:p>
@@ -2356,7 +2356,7 @@
           <a:p>
             <a:fld id="{CAE74E6A-A957-4BF9-843A-15390439D182}" type="datetimeFigureOut">
               <a:rPr lang="ko-KR" altLang="en-US" smtClean="0"/>
-              <a:t>2026-06-25</a:t>
+              <a:t>2026-06-30</a:t>
             </a:fld>
             <a:endParaRPr lang="ko-KR" altLang="en-US"/>
           </a:p>
@@ -2569,7 +2569,7 @@
           <a:p>
             <a:fld id="{CAE74E6A-A957-4BF9-843A-15390439D182}" type="datetimeFigureOut">
               <a:rPr lang="ko-KR" altLang="en-US" smtClean="0"/>
-              <a:t>2026-06-25</a:t>
+              <a:t>2026-06-30</a:t>
             </a:fld>
             <a:endParaRPr lang="ko-KR" altLang="en-US"/>
           </a:p>
@@ -3004,43 +3004,6 @@
           <a:xfrm>
             <a:off x="232660" y="1519610"/>
             <a:ext cx="13837184" cy="10708249"/>
-          </a:xfrm>
-          <a:prstGeom prst="rect">
-            <a:avLst/>
-          </a:prstGeom>
-        </p:spPr>
-      </p:pic>
-      <p:pic>
-        <p:nvPicPr>
-          <p:cNvPr id="4" name="그림 3">
-            <a:extLst>
-              <a:ext uri="{FF2B5EF4-FFF2-40B4-BE49-F238E27FC236}">
-                <a16:creationId xmlns:a16="http://schemas.microsoft.com/office/drawing/2014/main" id="{62D2285A-AB4E-2478-474D-59D086B78D8D}"/>
-              </a:ext>
-            </a:extLst>
-          </p:cNvPr>
-          <p:cNvPicPr>
-            <a:picLocks noChangeAspect="1"/>
-          </p:cNvPicPr>
-          <p:nvPr/>
-        </p:nvPicPr>
-        <p:blipFill>
-          <a:blip r:embed="rId3">
-            <a:alphaModFix amt="50000"/>
-            <a:extLst>
-              <a:ext uri="{28A0092B-C50C-407E-A947-70E740481C1C}">
-                <a14:useLocalDpi xmlns:a14="http://schemas.microsoft.com/office/drawing/2010/main" val="0"/>
-              </a:ext>
-            </a:extLst>
-          </a:blip>
-          <a:stretch>
-            <a:fillRect/>
-          </a:stretch>
-        </p:blipFill>
-        <p:spPr>
-          <a:xfrm>
-            <a:off x="110740" y="1285682"/>
-            <a:ext cx="14042863" cy="11124000"/>
           </a:xfrm>
           <a:prstGeom prst="rect">
             <a:avLst/>

</xml_diff>